<commit_message>
Microsoft Office fixtures re-saved after the rename; last ox leftovers fixed
- examples/hello-table/fixtures/*.msoffice-flow-*: the maintainer's seven saves (Excel 16.03, Word and
  PowerPoint 16.0 for Mac) from fresh Demo B exports; last-modified-by Milleleaf, folder path
  trimmed to ~/.
- run.sh and tools/inventory/roundtrip.sh called target/debug/ox; the binary is now mleaf.
- README, model.rs and schema/mleaf.tsp still named schema/ox.tsp.

Box: Rust tests 192 passed, 0 failed, 9 ignored; run.sh steps 1-19 exit 0; site build, CSP,
typecheck, check, check-compare, check-privacy and check-flow exit 0.
</commit_message>
<xml_diff>
--- a/examples/hello-table/fixtures/deck.msoffice-flow-edited.pptx
+++ b/examples/hello-table/fixtures/deck.msoffice-flow-edited.pptx
@@ -172,7 +172,7 @@
           </c:val>
           <c:extLst>
             <c:ext xmlns:c16="http://schemas.microsoft.com/office/drawing/2014/chart" uri="{C3380CC4-5D6E-409C-BE32-E72D297353CC}">
-              <c16:uniqueId val="{00000000-4666-F34C-8B4A-0F8B93993D73}"/>
+              <c16:uniqueId val="{00000000-7469-E44C-9A6F-E9EE78C799E2}"/>
             </c:ext>
           </c:extLst>
         </c:ser>
@@ -2997,7 +2997,7 @@
 
 <file path=ppt/slides/slide1.xml><?xml version="1.0" encoding="utf-8"?>
 <p:sld xmlns:a="http://schemas.openxmlformats.org/drawingml/2006/main" xmlns:r="http://schemas.openxmlformats.org/officeDocument/2006/relationships" xmlns:p="http://schemas.openxmlformats.org/presentationml/2006/main">
-  <p:cSld name="ox:flow-slide">
+  <p:cSld name="mleaf:flow-slide">
     <p:bg>
       <p:bgPr>
         <a:solidFill>
@@ -3022,7 +3022,7 @@
       </p:grpSpPr>
       <p:sp>
         <p:nvSpPr>
-          <p:cNvPr id="258" name="ox:flow-deck-title"/>
+          <p:cNvPr id="258" name="mleaf:flow-deck-title"/>
           <p:cNvSpPr txBox="1"/>
           <p:nvPr/>
         </p:nvSpPr>
@@ -3045,13 +3045,26 @@
           </a:bodyPr>
           <a:lstStyle/>
           <a:p>
+            <a:pPr algn="l">
+              <a:buNone/>
+            </a:pPr>
             <a:r>
-              <a:rPr lang="en-US" sz="3000">
+              <a:rPr sz="3000" dirty="0">
                 <a:solidFill>
                   <a:srgbClr val="183D4D"/>
                 </a:solidFill>
+                <a:latin typeface="Inter"/>
               </a:rPr>
-              <a:t>Workbook figures reviewed</a:t>
+              <a:t>Workbook figures</a:t>
+            </a:r>
+            <a:r>
+              <a:rPr lang="en-AU" sz="3000" dirty="0">
+                <a:solidFill>
+                  <a:srgbClr val="183D4D"/>
+                </a:solidFill>
+                <a:latin typeface="Inter"/>
+              </a:rPr>
+              <a:t> reviewed in PowerPoint</a:t>
             </a:r>
             <a:endParaRPr sz="3000" dirty="0">
               <a:solidFill>
@@ -3064,7 +3077,7 @@
       </p:sp>
       <p:graphicFrame>
         <p:nvGraphicFramePr>
-          <p:cNvPr id="259" name="ox:flow-deck-table"/>
+          <p:cNvPr id="259" name="mleaf:flow-deck-table"/>
           <p:cNvGraphicFramePr>
             <a:graphicFrameLocks noGrp="1"/>
           </p:cNvGraphicFramePr>
@@ -3258,7 +3271,7 @@
       </p:graphicFrame>
       <p:graphicFrame>
         <p:nvGraphicFramePr>
-          <p:cNvPr id="260" name="ox:flow-deck-chart"/>
+          <p:cNvPr id="260" name="mleaf:flow-deck-chart"/>
           <p:cNvGraphicFramePr>
             <a:graphicFrameLocks noGrp="1"/>
           </p:cNvGraphicFramePr>

</xml_diff>